<commit_message>
docs(deck): add Testing & Verification + Proposed applied example (60s demo) slides
Co-Authored-By: Claude Opus 4.8 <noreply@anthropic.com>
</commit_message>
<xml_diff>
--- a/presentation/hackathon.pptx
+++ b/presentation/hackathon.pptx
@@ -17,9 +17,11 @@
     <p:sldId id="265" r:id="rId11"/>
     <p:sldId id="266" r:id="rId12"/>
     <p:sldId id="267" r:id="rId13"/>
+    <p:sldId id="268" r:id="rId14"/>
+    <p:sldId id="269" r:id="rId15"/>
   </p:sldIdLst>
   <p:notesMasterIdLst>
-    <p:notesMasterId r:id="rId14"/>
+    <p:notesMasterId r:id="rId16"/>
   </p:notesMasterIdLst>
   <p:sldSz cx="12192000" cy="6858000"/>
   <p:notesSz cx="6858000" cy="12192000"/>
@@ -801,6 +803,182 @@
             <a:fld id="{F7021451-1387-4CA6-816F-3879F97B5CBC}" type="slidenum">
               <a:rPr lang="en-US"/>
               <a:t>12</a:t>
+            </a:fld>
+            <a:endParaRPr lang="en-US"/>
+          </a:p>
+        </p:txBody>
+      </p:sp>
+    </p:spTree>
+    <p:extLst>
+      <p:ext uri="{BB962C8B-B14F-4D97-AF65-F5344CB8AC3E}">
+        <p14:creationId xmlns:p14="http://schemas.microsoft.com/office/powerpoint/2010/main" val="1024086991"/>
+      </p:ext>
+    </p:extLst>
+  </p:cSld>
+  <p:clrMapOvr>
+    <a:masterClrMapping/>
+  </p:clrMapOvr>
+</p:notes>
+</file>
+
+<file path=ppt/notesSlides/notesSlide13.xml><?xml version="1.0" encoding="utf-8"?>
+<p:notes xmlns:a="http://schemas.openxmlformats.org/drawingml/2006/main" xmlns:r="http://schemas.openxmlformats.org/officeDocument/2006/relationships" xmlns:p="http://schemas.openxmlformats.org/presentationml/2006/main">
+  <p:cSld>
+    <p:spTree>
+      <p:nvGrpSpPr>
+        <p:cNvPr id="1" name=""/>
+        <p:cNvGrpSpPr/>
+        <p:nvPr/>
+      </p:nvGrpSpPr>
+      <p:grpSpPr>
+        <a:xfrm>
+          <a:off x="0" y="0"/>
+          <a:ext cx="0" cy="0"/>
+          <a:chOff x="0" y="0"/>
+          <a:chExt cx="0" cy="0"/>
+        </a:xfrm>
+      </p:grpSpPr>
+      <p:sp>
+        <p:nvSpPr>
+          <p:cNvPr id="2" name="Slide Image Placeholder 1"/>
+          <p:cNvSpPr>
+            <a:spLocks noGrp="1" noRot="1" noChangeAspect="1"/>
+          </p:cNvSpPr>
+          <p:nvPr>
+            <p:ph type="sldImg"/>
+          </p:nvPr>
+        </p:nvSpPr>
+        <p:spPr/>
+      </p:sp>
+      <p:sp>
+        <p:nvSpPr>
+          <p:cNvPr id="3" name="Notes Placeholder 2"/>
+          <p:cNvSpPr>
+            <a:spLocks noGrp="1"/>
+          </p:cNvSpPr>
+          <p:nvPr>
+            <p:ph type="body" idx="1"/>
+          </p:nvPr>
+        </p:nvSpPr>
+        <p:spPr/>
+        <p:txBody>
+          <a:bodyPr/>
+          <a:lstStyle/>
+          <a:p>
+            <a:r>
+              <a:rPr lang="en-US" dirty="0"/>
+              <a:t/>
+            </a:r>
+            <a:endParaRPr lang="en-US" dirty="0"/>
+          </a:p>
+        </p:txBody>
+      </p:sp>
+      <p:sp>
+        <p:nvSpPr>
+          <p:cNvPr id="4" name="Slide Number Placeholder 3"/>
+          <p:cNvSpPr>
+            <a:spLocks noGrp="1"/>
+          </p:cNvSpPr>
+          <p:nvPr>
+            <p:ph type="sldNum" sz="quarter" idx="10"/>
+          </p:nvPr>
+        </p:nvSpPr>
+        <p:spPr/>
+        <p:txBody>
+          <a:bodyPr/>
+          <a:lstStyle/>
+          <a:p>
+            <a:fld id="{F7021451-1387-4CA6-816F-3879F97B5CBC}" type="slidenum">
+              <a:rPr lang="en-US"/>
+              <a:t>13</a:t>
+            </a:fld>
+            <a:endParaRPr lang="en-US"/>
+          </a:p>
+        </p:txBody>
+      </p:sp>
+    </p:spTree>
+    <p:extLst>
+      <p:ext uri="{BB962C8B-B14F-4D97-AF65-F5344CB8AC3E}">
+        <p14:creationId xmlns:p14="http://schemas.microsoft.com/office/powerpoint/2010/main" val="1024086991"/>
+      </p:ext>
+    </p:extLst>
+  </p:cSld>
+  <p:clrMapOvr>
+    <a:masterClrMapping/>
+  </p:clrMapOvr>
+</p:notes>
+</file>
+
+<file path=ppt/notesSlides/notesSlide14.xml><?xml version="1.0" encoding="utf-8"?>
+<p:notes xmlns:a="http://schemas.openxmlformats.org/drawingml/2006/main" xmlns:r="http://schemas.openxmlformats.org/officeDocument/2006/relationships" xmlns:p="http://schemas.openxmlformats.org/presentationml/2006/main">
+  <p:cSld>
+    <p:spTree>
+      <p:nvGrpSpPr>
+        <p:cNvPr id="1" name=""/>
+        <p:cNvGrpSpPr/>
+        <p:nvPr/>
+      </p:nvGrpSpPr>
+      <p:grpSpPr>
+        <a:xfrm>
+          <a:off x="0" y="0"/>
+          <a:ext cx="0" cy="0"/>
+          <a:chOff x="0" y="0"/>
+          <a:chExt cx="0" cy="0"/>
+        </a:xfrm>
+      </p:grpSpPr>
+      <p:sp>
+        <p:nvSpPr>
+          <p:cNvPr id="2" name="Slide Image Placeholder 1"/>
+          <p:cNvSpPr>
+            <a:spLocks noGrp="1" noRot="1" noChangeAspect="1"/>
+          </p:cNvSpPr>
+          <p:nvPr>
+            <p:ph type="sldImg"/>
+          </p:nvPr>
+        </p:nvSpPr>
+        <p:spPr/>
+      </p:sp>
+      <p:sp>
+        <p:nvSpPr>
+          <p:cNvPr id="3" name="Notes Placeholder 2"/>
+          <p:cNvSpPr>
+            <a:spLocks noGrp="1"/>
+          </p:cNvSpPr>
+          <p:nvPr>
+            <p:ph type="body" idx="1"/>
+          </p:nvPr>
+        </p:nvSpPr>
+        <p:spPr/>
+        <p:txBody>
+          <a:bodyPr/>
+          <a:lstStyle/>
+          <a:p>
+            <a:r>
+              <a:rPr lang="en-US" dirty="0"/>
+              <a:t/>
+            </a:r>
+            <a:endParaRPr lang="en-US" dirty="0"/>
+          </a:p>
+        </p:txBody>
+      </p:sp>
+      <p:sp>
+        <p:nvSpPr>
+          <p:cNvPr id="4" name="Slide Number Placeholder 3"/>
+          <p:cNvSpPr>
+            <a:spLocks noGrp="1"/>
+          </p:cNvSpPr>
+          <p:nvPr>
+            <p:ph type="sldNum" sz="quarter" idx="10"/>
+          </p:nvPr>
+        </p:nvSpPr>
+        <p:spPr/>
+        <p:txBody>
+          <a:bodyPr/>
+          <a:lstStyle/>
+          <a:p>
+            <a:fld id="{F7021451-1387-4CA6-816F-3879F97B5CBC}" type="slidenum">
+              <a:rPr lang="en-US"/>
+              <a:t>14</a:t>
             </a:fld>
             <a:endParaRPr lang="en-US"/>
           </a:p>
@@ -2678,7 +2856,7 @@
                 <a:ea typeface="Arial" pitchFamily="34" charset="-122"/>
                 <a:cs typeface="Arial" pitchFamily="34" charset="-120"/>
               </a:rPr>
-              <a:t>الذكاء الاصطناعي (rule-engine → ML)</a:t>
+              <a:t>الاختبار والتحقق</a:t>
             </a:r>
             <a:endParaRPr lang="en-US" sz="3200" dirty="0"/>
           </a:p>
@@ -2692,12 +2870,12 @@
         </p:nvSpPr>
         <p:spPr>
           <a:xfrm>
-            <a:off x="640080" y="1554480"/>
-            <a:ext cx="5349240" cy="1417320"/>
+            <a:off x="6172200" y="1554480"/>
+            <a:ext cx="5349240" cy="4297680"/>
           </a:xfrm>
           <a:prstGeom prst="roundRect">
             <a:avLst>
-              <a:gd name="adj" fmla="val 7742"/>
+              <a:gd name="adj" fmla="val 2553"/>
             </a:avLst>
           </a:prstGeom>
           <a:solidFill>
@@ -2720,23 +2898,42 @@
       </p:sp>
       <p:sp>
         <p:nvSpPr>
-          <p:cNvPr id="4" name="Shape 2"/>
-          <p:cNvSpPr/>
-          <p:nvPr/>
-        </p:nvSpPr>
-        <p:spPr>
-          <a:xfrm>
-            <a:off x="5120640" y="1783080"/>
-            <a:ext cx="548640" cy="548640"/>
-          </a:xfrm>
-          <a:prstGeom prst="ellipse">
-            <a:avLst/>
-          </a:prstGeom>
-          <a:solidFill>
-            <a:srgbClr val="27305A"/>
-          </a:solidFill>
-          <a:ln/>
-        </p:spPr>
+          <p:cNvPr id="4" name="Text 2"/>
+          <p:cNvSpPr/>
+          <p:nvPr/>
+        </p:nvSpPr>
+        <p:spPr>
+          <a:xfrm>
+            <a:off x="6355080" y="1737360"/>
+            <a:ext cx="4937760" cy="457200"/>
+          </a:xfrm>
+          <a:prstGeom prst="rect">
+            <a:avLst/>
+          </a:prstGeom>
+          <a:noFill/>
+          <a:ln/>
+        </p:spPr>
+        <p:txBody>
+          <a:bodyPr wrap="square" lIns="0" tIns="0" rIns="0" bIns="0" rtlCol="0" anchor="ctr"/>
+          <a:lstStyle/>
+          <a:p>
+            <a:pPr rtl="1" algn="r" indent="0" marL="0">
+              <a:buNone/>
+            </a:pPr>
+            <a:r>
+              <a:rPr lang="en-US" sz="1800" b="1" dirty="0">
+                <a:solidFill>
+                  <a:srgbClr val="34D399"/>
+                </a:solidFill>
+                <a:latin typeface="Arial" pitchFamily="34" charset="0"/>
+                <a:ea typeface="Arial" pitchFamily="34" charset="-122"/>
+                <a:cs typeface="Arial" pitchFamily="34" charset="-120"/>
+              </a:rPr>
+              <a:t>منهجية الاختبار</a:t>
+            </a:r>
+            <a:endParaRPr lang="en-US" sz="1800" dirty="0"/>
+          </a:p>
+        </p:txBody>
       </p:sp>
       <p:sp>
         <p:nvSpPr>
@@ -2746,60 +2943,28 @@
         </p:nvSpPr>
         <p:spPr>
           <a:xfrm>
-            <a:off x="5120640" y="1783080"/>
-            <a:ext cx="548640" cy="548640"/>
-          </a:xfrm>
-          <a:prstGeom prst="rect">
-            <a:avLst/>
-          </a:prstGeom>
-          <a:noFill/>
-          <a:ln/>
-        </p:spPr>
-        <p:txBody>
-          <a:bodyPr wrap="square" lIns="0" tIns="0" rIns="0" bIns="0" rtlCol="0" anchor="ctr"/>
-          <a:lstStyle/>
-          <a:p>
-            <a:pPr algn="ctr" indent="0" marL="0">
-              <a:buNone/>
-            </a:pPr>
-            <a:r>
-              <a:rPr lang="en-US" sz="2200" dirty="0">
-                <a:solidFill>
-                  <a:srgbClr val="000000"/>
-                </a:solidFill>
-              </a:rPr>
-              <a:t>🎯</a:t>
-            </a:r>
-            <a:endParaRPr lang="en-US" sz="2200" dirty="0"/>
-          </a:p>
-        </p:txBody>
-      </p:sp>
-      <p:sp>
-        <p:nvSpPr>
-          <p:cNvPr id="6" name="Text 4"/>
-          <p:cNvSpPr/>
-          <p:nvPr/>
-        </p:nvSpPr>
-        <p:spPr>
-          <a:xfrm>
-            <a:off x="914400" y="1755648"/>
-            <a:ext cx="4069080" cy="457200"/>
-          </a:xfrm>
-          <a:prstGeom prst="rect">
-            <a:avLst/>
-          </a:prstGeom>
-          <a:noFill/>
-          <a:ln/>
-        </p:spPr>
-        <p:txBody>
-          <a:bodyPr wrap="square" lIns="0" tIns="0" rIns="0" bIns="0" rtlCol="0" anchor="ctr"/>
-          <a:lstStyle/>
-          <a:p>
-            <a:pPr rtl="1" algn="r" indent="0" marL="0">
-              <a:buNone/>
-            </a:pPr>
-            <a:r>
-              <a:rPr lang="en-US" sz="1700" b="1" dirty="0">
+            <a:off x="6355080" y="2286000"/>
+            <a:ext cx="4937760" cy="3383280"/>
+          </a:xfrm>
+          <a:prstGeom prst="rect">
+            <a:avLst/>
+          </a:prstGeom>
+          <a:noFill/>
+          <a:ln/>
+        </p:spPr>
+        <p:txBody>
+          <a:bodyPr wrap="square" rtlCol="0" anchor="ctr"/>
+          <a:lstStyle/>
+          <a:p>
+            <a:pPr algn="r" marL="342900" indent="-342900">
+              <a:lnSpc>
+                <a:spcPct val="135000"/>
+              </a:lnSpc>
+              <a:buSzPct val="100000"/>
+              <a:buChar char="•"/>
+            </a:pPr>
+            <a:r>
+              <a:rPr lang="en-US" sz="1450" dirty="0">
                 <a:solidFill>
                   <a:srgbClr val="EEF1FF"/>
                 </a:solidFill>
@@ -2807,65 +2972,110 @@
                 <a:ea typeface="Arial" pitchFamily="34" charset="-122"/>
                 <a:cs typeface="Arial" pitchFamily="34" charset="-120"/>
               </a:rPr>
-              <a:t>اختيار الوحش</a:t>
-            </a:r>
-            <a:endParaRPr lang="en-US" sz="1700" dirty="0"/>
-          </a:p>
-        </p:txBody>
-      </p:sp>
-      <p:sp>
-        <p:nvSpPr>
-          <p:cNvPr id="7" name="Text 5"/>
-          <p:cNvSpPr/>
-          <p:nvPr/>
-        </p:nvSpPr>
-        <p:spPr>
-          <a:xfrm>
-            <a:off x="914400" y="2212848"/>
-            <a:ext cx="4069080" cy="594360"/>
-          </a:xfrm>
-          <a:prstGeom prst="rect">
-            <a:avLst/>
-          </a:prstGeom>
-          <a:noFill/>
-          <a:ln/>
-        </p:spPr>
-        <p:txBody>
-          <a:bodyPr wrap="square" lIns="0" tIns="0" rIns="0" bIns="0" rtlCol="0" anchor="t"/>
-          <a:lstStyle/>
-          <a:p>
-            <a:pPr rtl="1" algn="r" indent="0" marL="0">
-              <a:buNone/>
-            </a:pPr>
-            <a:r>
-              <a:rPr lang="en-US" sz="1250" dirty="0">
-                <a:solidFill>
-                  <a:srgbClr val="A7ADCE"/>
-                </a:solidFill>
-                <a:latin typeface="Arial" pitchFamily="34" charset="0"/>
-                <a:ea typeface="Arial" pitchFamily="34" charset="-122"/>
-                <a:cs typeface="Arial" pitchFamily="34" charset="-120"/>
-              </a:rPr>
-              <a:t>يستهدف أضعف مهارة لدى الطفل.</a:t>
-            </a:r>
-            <a:endParaRPr lang="en-US" sz="1250" dirty="0"/>
-          </a:p>
-        </p:txBody>
-      </p:sp>
-      <p:sp>
-        <p:nvSpPr>
-          <p:cNvPr id="8" name="Shape 6"/>
-          <p:cNvSpPr/>
-          <p:nvPr/>
-        </p:nvSpPr>
-        <p:spPr>
-          <a:xfrm>
-            <a:off x="6172200" y="1554480"/>
-            <a:ext cx="5349240" cy="1417320"/>
+              <a:t>26 اختبار وحدة وتكامل آليّة.</a:t>
+            </a:r>
+            <a:endParaRPr lang="en-US" sz="1450" dirty="0"/>
+          </a:p>
+          <a:p>
+            <a:pPr algn="r" marL="342900" indent="-342900">
+              <a:lnSpc>
+                <a:spcPct val="135000"/>
+              </a:lnSpc>
+              <a:buSzPct val="100000"/>
+              <a:buChar char="•"/>
+            </a:pPr>
+            <a:r>
+              <a:rPr lang="en-US" sz="1450" dirty="0">
+                <a:solidFill>
+                  <a:srgbClr val="EEF1FF"/>
+                </a:solidFill>
+                <a:latin typeface="Arial" pitchFamily="34" charset="0"/>
+                <a:ea typeface="Arial" pitchFamily="34" charset="-122"/>
+                <a:cs typeface="Arial" pitchFamily="34" charset="-120"/>
+              </a:rPr>
+              <a:t>اختبار e2e كامل على Postgres حقيقي (مدمج).</a:t>
+            </a:r>
+            <a:endParaRPr lang="en-US" sz="1450" dirty="0"/>
+          </a:p>
+          <a:p>
+            <a:pPr algn="r" marL="342900" indent="-342900">
+              <a:lnSpc>
+                <a:spcPct val="135000"/>
+              </a:lnSpc>
+              <a:buSzPct val="100000"/>
+              <a:buChar char="•"/>
+            </a:pPr>
+            <a:r>
+              <a:rPr lang="en-US" sz="1450" dirty="0">
+                <a:solidFill>
+                  <a:srgbClr val="EEF1FF"/>
+                </a:solidFill>
+                <a:latin typeface="Arial" pitchFamily="34" charset="0"/>
+                <a:ea typeface="Arial" pitchFamily="34" charset="-122"/>
+                <a:cs typeface="Arial" pitchFamily="34" charset="-120"/>
+              </a:rPr>
+              <a:t>تجربة حيّة للواجهة في المتصفح خطوة بخطوة.</a:t>
+            </a:r>
+            <a:endParaRPr lang="en-US" sz="1450" dirty="0"/>
+          </a:p>
+          <a:p>
+            <a:pPr algn="r" marL="342900" indent="-342900">
+              <a:lnSpc>
+                <a:spcPct val="135000"/>
+              </a:lnSpc>
+              <a:buSzPct val="100000"/>
+              <a:buChar char="•"/>
+            </a:pPr>
+            <a:r>
+              <a:rPr lang="en-US" sz="1450" dirty="0">
+                <a:solidFill>
+                  <a:srgbClr val="EEF1FF"/>
+                </a:solidFill>
+                <a:latin typeface="Arial" pitchFamily="34" charset="0"/>
+                <a:ea typeface="Arial" pitchFamily="34" charset="-122"/>
+                <a:cs typeface="Arial" pitchFamily="34" charset="-120"/>
+              </a:rPr>
+              <a:t>تحقق منطق الفتح: idempotent ولا تراجع في الرصيد.</a:t>
+            </a:r>
+            <a:endParaRPr lang="en-US" sz="1450" dirty="0"/>
+          </a:p>
+          <a:p>
+            <a:pPr algn="r" marL="342900" indent="-342900">
+              <a:lnSpc>
+                <a:spcPct val="135000"/>
+              </a:lnSpc>
+              <a:buSzPct val="100000"/>
+              <a:buChar char="•"/>
+            </a:pPr>
+            <a:r>
+              <a:rPr lang="en-US" sz="1450" dirty="0">
+                <a:solidFill>
+                  <a:srgbClr val="EEF1FF"/>
+                </a:solidFill>
+                <a:latin typeface="Arial" pitchFamily="34" charset="0"/>
+                <a:ea typeface="Arial" pitchFamily="34" charset="-122"/>
+                <a:cs typeface="Arial" pitchFamily="34" charset="-120"/>
+              </a:rPr>
+              <a:t>توليد DDL للهجرات والتحقق منه دون قاعدة.</a:t>
+            </a:r>
+            <a:endParaRPr lang="en-US" sz="1450" dirty="0"/>
+          </a:p>
+        </p:txBody>
+      </p:sp>
+      <p:sp>
+        <p:nvSpPr>
+          <p:cNvPr id="6" name="Shape 4"/>
+          <p:cNvSpPr/>
+          <p:nvPr/>
+        </p:nvSpPr>
+        <p:spPr>
+          <a:xfrm>
+            <a:off x="640080" y="1554480"/>
+            <a:ext cx="5349240" cy="4297680"/>
           </a:xfrm>
           <a:prstGeom prst="roundRect">
             <a:avLst>
-              <a:gd name="adj" fmla="val 7742"/>
+              <a:gd name="adj" fmla="val 2553"/>
             </a:avLst>
           </a:prstGeom>
           <a:solidFill>
@@ -2888,34 +3098,14 @@
       </p:sp>
       <p:sp>
         <p:nvSpPr>
-          <p:cNvPr id="9" name="Shape 7"/>
-          <p:cNvSpPr/>
-          <p:nvPr/>
-        </p:nvSpPr>
-        <p:spPr>
-          <a:xfrm>
-            <a:off x="10652760" y="1783080"/>
-            <a:ext cx="548640" cy="548640"/>
-          </a:xfrm>
-          <a:prstGeom prst="ellipse">
-            <a:avLst/>
-          </a:prstGeom>
-          <a:solidFill>
-            <a:srgbClr val="27305A"/>
-          </a:solidFill>
-          <a:ln/>
-        </p:spPr>
-      </p:sp>
-      <p:sp>
-        <p:nvSpPr>
-          <p:cNvPr id="10" name="Text 8"/>
-          <p:cNvSpPr/>
-          <p:nvPr/>
-        </p:nvSpPr>
-        <p:spPr>
-          <a:xfrm>
-            <a:off x="10652760" y="1783080"/>
-            <a:ext cx="548640" cy="548640"/>
+          <p:cNvPr id="7" name="Text 5"/>
+          <p:cNvSpPr/>
+          <p:nvPr/>
+        </p:nvSpPr>
+        <p:spPr>
+          <a:xfrm>
+            <a:off x="822960" y="1737360"/>
+            <a:ext cx="4937760" cy="457200"/>
           </a:xfrm>
           <a:prstGeom prst="rect">
             <a:avLst/>
@@ -2927,31 +3117,140 @@
           <a:bodyPr wrap="square" lIns="0" tIns="0" rIns="0" bIns="0" rtlCol="0" anchor="ctr"/>
           <a:lstStyle/>
           <a:p>
-            <a:pPr algn="ctr" indent="0" marL="0">
-              <a:buNone/>
-            </a:pPr>
-            <a:r>
-              <a:rPr lang="en-US" sz="2200" dirty="0">
-                <a:solidFill>
-                  <a:srgbClr val="000000"/>
-                </a:solidFill>
-              </a:rPr>
-              <a:t>⚖️</a:t>
-            </a:r>
-            <a:endParaRPr lang="en-US" sz="2200" dirty="0"/>
-          </a:p>
-        </p:txBody>
-      </p:sp>
-      <p:sp>
-        <p:nvSpPr>
-          <p:cNvPr id="11" name="Text 9"/>
-          <p:cNvSpPr/>
-          <p:nvPr/>
-        </p:nvSpPr>
-        <p:spPr>
-          <a:xfrm>
-            <a:off x="6446520" y="1755648"/>
-            <a:ext cx="4069080" cy="457200"/>
+            <a:pPr rtl="1" algn="r" indent="0" marL="0">
+              <a:buNone/>
+            </a:pPr>
+            <a:r>
+              <a:rPr lang="en-US" sz="1800" b="1" dirty="0">
+                <a:solidFill>
+                  <a:srgbClr val="FFC24D"/>
+                </a:solidFill>
+                <a:latin typeface="Arial" pitchFamily="34" charset="0"/>
+                <a:ea typeface="Arial" pitchFamily="34" charset="-122"/>
+                <a:cs typeface="Arial" pitchFamily="34" charset="-120"/>
+              </a:rPr>
+              <a:t>نتائج التحقق</a:t>
+            </a:r>
+            <a:endParaRPr lang="en-US" sz="1800" dirty="0"/>
+          </a:p>
+        </p:txBody>
+      </p:sp>
+      <p:sp>
+        <p:nvSpPr>
+          <p:cNvPr id="8" name="Text 6"/>
+          <p:cNvSpPr/>
+          <p:nvPr/>
+        </p:nvSpPr>
+        <p:spPr>
+          <a:xfrm>
+            <a:off x="822960" y="2286000"/>
+            <a:ext cx="4937760" cy="3383280"/>
+          </a:xfrm>
+          <a:prstGeom prst="rect">
+            <a:avLst/>
+          </a:prstGeom>
+          <a:noFill/>
+          <a:ln/>
+        </p:spPr>
+        <p:txBody>
+          <a:bodyPr wrap="square" rtlCol="0" anchor="ctr"/>
+          <a:lstStyle/>
+          <a:p>
+            <a:pPr algn="r" marL="342900" indent="-342900">
+              <a:lnSpc>
+                <a:spcPct val="135000"/>
+              </a:lnSpc>
+              <a:buSzPct val="100000"/>
+              <a:buChar char="•"/>
+            </a:pPr>
+            <a:r>
+              <a:rPr lang="en-US" sz="1450" dirty="0">
+                <a:solidFill>
+                  <a:srgbClr val="EEF1FF"/>
+                </a:solidFill>
+                <a:latin typeface="Arial" pitchFamily="34" charset="0"/>
+                <a:ea typeface="Arial" pitchFamily="34" charset="-122"/>
+                <a:cs typeface="Arial" pitchFamily="34" charset="-120"/>
+              </a:rPr>
+              <a:t>26/26 اختبار ناجح ✅</a:t>
+            </a:r>
+            <a:endParaRPr lang="en-US" sz="1450" dirty="0"/>
+          </a:p>
+          <a:p>
+            <a:pPr algn="r" marL="342900" indent="-342900">
+              <a:lnSpc>
+                <a:spcPct val="135000"/>
+              </a:lnSpc>
+              <a:buSzPct val="100000"/>
+              <a:buChar char="•"/>
+            </a:pPr>
+            <a:r>
+              <a:rPr lang="en-US" sz="1450" dirty="0">
+                <a:solidFill>
+                  <a:srgbClr val="EEF1FF"/>
+                </a:solidFill>
+                <a:latin typeface="Arial" pitchFamily="34" charset="0"/>
+                <a:ea typeface="Arial" pitchFamily="34" charset="-122"/>
+                <a:cs typeface="Arial" pitchFamily="34" charset="-120"/>
+              </a:rPr>
+              <a:t>التدفّق الكامل يعمل: من الطلب حتى فتح 500 Robux.</a:t>
+            </a:r>
+            <a:endParaRPr lang="en-US" sz="1450" dirty="0"/>
+          </a:p>
+          <a:p>
+            <a:pPr algn="r" marL="342900" indent="-342900">
+              <a:lnSpc>
+                <a:spcPct val="135000"/>
+              </a:lnSpc>
+              <a:buSzPct val="100000"/>
+              <a:buChar char="•"/>
+            </a:pPr>
+            <a:r>
+              <a:rPr lang="en-US" sz="1450" dirty="0">
+                <a:solidFill>
+                  <a:srgbClr val="EEF1FF"/>
+                </a:solidFill>
+                <a:latin typeface="Arial" pitchFamily="34" charset="0"/>
+                <a:ea typeface="Arial" pitchFamily="34" charset="-122"/>
+                <a:cs typeface="Arial" pitchFamily="34" charset="-120"/>
+              </a:rPr>
+              <a:t>بق حقيقي اكتشفه المتصفح (تقدّم المكافأة) → أُصلح + اختبار يمنع تكراره.</a:t>
+            </a:r>
+            <a:endParaRPr lang="en-US" sz="1450" dirty="0"/>
+          </a:p>
+          <a:p>
+            <a:pPr algn="r" marL="342900" indent="-342900">
+              <a:lnSpc>
+                <a:spcPct val="135000"/>
+              </a:lnSpc>
+              <a:buSzPct val="100000"/>
+              <a:buChar char="•"/>
+            </a:pPr>
+            <a:r>
+              <a:rPr lang="en-US" sz="1450" dirty="0">
+                <a:solidFill>
+                  <a:srgbClr val="EEF1FF"/>
+                </a:solidFill>
+                <a:latin typeface="Arial" pitchFamily="34" charset="0"/>
+                <a:ea typeface="Arial" pitchFamily="34" charset="-122"/>
+                <a:cs typeface="Arial" pitchFamily="34" charset="-120"/>
+              </a:rPr>
+              <a:t>لا تسرّب بيانات أطفال، والمال بحساب Decimal آمن.</a:t>
+            </a:r>
+            <a:endParaRPr lang="en-US" sz="1450" dirty="0"/>
+          </a:p>
+        </p:txBody>
+      </p:sp>
+      <p:sp>
+        <p:nvSpPr>
+          <p:cNvPr id="9" name="Text 7"/>
+          <p:cNvSpPr/>
+          <p:nvPr/>
+        </p:nvSpPr>
+        <p:spPr>
+          <a:xfrm>
+            <a:off x="548640" y="6309360"/>
+            <a:ext cx="11064240" cy="365760"/>
           </a:xfrm>
           <a:prstGeom prst="rect">
             <a:avLst/>
@@ -2967,73 +3266,105 @@
               <a:buNone/>
             </a:pPr>
             <a:r>
-              <a:rPr lang="en-US" sz="1700" b="1" dirty="0">
-                <a:solidFill>
-                  <a:srgbClr val="EEF1FF"/>
-                </a:solidFill>
-                <a:latin typeface="Arial" pitchFamily="34" charset="0"/>
-                <a:ea typeface="Arial" pitchFamily="34" charset="-122"/>
-                <a:cs typeface="Arial" pitchFamily="34" charset="-120"/>
-              </a:rPr>
-              <a:t>تعديل الصعوبة</a:t>
-            </a:r>
-            <a:endParaRPr lang="en-US" sz="1700" dirty="0"/>
-          </a:p>
-        </p:txBody>
-      </p:sp>
-      <p:sp>
-        <p:nvSpPr>
-          <p:cNvPr id="12" name="Text 10"/>
-          <p:cNvSpPr/>
-          <p:nvPr/>
-        </p:nvSpPr>
-        <p:spPr>
-          <a:xfrm>
-            <a:off x="6446520" y="2212848"/>
-            <a:ext cx="4069080" cy="594360"/>
-          </a:xfrm>
-          <a:prstGeom prst="rect">
-            <a:avLst/>
-          </a:prstGeom>
-          <a:noFill/>
-          <a:ln/>
-        </p:spPr>
-        <p:txBody>
-          <a:bodyPr wrap="square" lIns="0" tIns="0" rIns="0" bIns="0" rtlCol="0" anchor="t"/>
+              <a:rPr lang="en-US" sz="1100" i="1" dirty="0">
+                <a:solidFill>
+                  <a:srgbClr val="A7ADCE"/>
+                </a:solidFill>
+                <a:latin typeface="Arial" pitchFamily="34" charset="0"/>
+                <a:ea typeface="Arial" pitchFamily="34" charset="-122"/>
+                <a:cs typeface="Arial" pitchFamily="34" charset="-120"/>
+              </a:rPr>
+              <a:t>التحقق ليس شرائح — كل نتيجة مثبتة بتشغيل فعلي على قاعدة حقيقية وفي المتصفح.</a:t>
+            </a:r>
+            <a:endParaRPr lang="en-US" sz="1100" dirty="0"/>
+          </a:p>
+        </p:txBody>
+      </p:sp>
+    </p:spTree>
+  </p:cSld>
+  <p:clrMapOvr>
+    <a:masterClrMapping/>
+  </p:clrMapOvr>
+</p:sld>
+</file>
+
+<file path=ppt/slides/slide12.xml><?xml version="1.0" encoding="utf-8"?>
+<p:sld xmlns:a="http://schemas.openxmlformats.org/drawingml/2006/main" xmlns:r="http://schemas.openxmlformats.org/officeDocument/2006/relationships" xmlns:p="http://schemas.openxmlformats.org/presentationml/2006/main">
+  <p:cSld name="Slide 12">
+    <p:bg>
+      <p:bgPr>
+        <a:solidFill>
+          <a:srgbClr val="141A33"/>
+        </a:solidFill>
+      </p:bgPr>
+    </p:bg>
+    <p:spTree>
+      <p:nvGrpSpPr>
+        <p:cNvPr id="1" name=""/>
+        <p:cNvGrpSpPr/>
+        <p:nvPr/>
+      </p:nvGrpSpPr>
+      <p:grpSpPr>
+        <a:xfrm>
+          <a:off x="0" y="0"/>
+          <a:ext cx="0" cy="0"/>
+          <a:chOff x="0" y="0"/>
+          <a:chExt cx="0" cy="0"/>
+        </a:xfrm>
+      </p:grpSpPr>
+      <p:sp>
+        <p:nvSpPr>
+          <p:cNvPr id="2" name="Text 0"/>
+          <p:cNvSpPr/>
+          <p:nvPr/>
+        </p:nvSpPr>
+        <p:spPr>
+          <a:xfrm>
+            <a:off x="548640" y="365760"/>
+            <a:ext cx="11064240" cy="822960"/>
+          </a:xfrm>
+          <a:prstGeom prst="rect">
+            <a:avLst/>
+          </a:prstGeom>
+          <a:noFill/>
+          <a:ln/>
+        </p:spPr>
+        <p:txBody>
+          <a:bodyPr wrap="square" rtlCol="0" anchor="ctr"/>
           <a:lstStyle/>
           <a:p>
             <a:pPr rtl="1" algn="r" indent="0" marL="0">
               <a:buNone/>
             </a:pPr>
             <a:r>
-              <a:rPr lang="en-US" sz="1250" dirty="0">
-                <a:solidFill>
-                  <a:srgbClr val="A7ADCE"/>
-                </a:solidFill>
-                <a:latin typeface="Arial" pitchFamily="34" charset="0"/>
-                <a:ea typeface="Arial" pitchFamily="34" charset="-122"/>
-                <a:cs typeface="Arial" pitchFamily="34" charset="-120"/>
-              </a:rPr>
-              <a:t>يبقي النجاح في منطقة النمو (~70–80%).</a:t>
-            </a:r>
-            <a:endParaRPr lang="en-US" sz="1250" dirty="0"/>
-          </a:p>
-        </p:txBody>
-      </p:sp>
-      <p:sp>
-        <p:nvSpPr>
-          <p:cNvPr id="13" name="Shape 11"/>
-          <p:cNvSpPr/>
-          <p:nvPr/>
-        </p:nvSpPr>
-        <p:spPr>
-          <a:xfrm>
-            <a:off x="640080" y="3108960"/>
-            <a:ext cx="5349240" cy="1417320"/>
+              <a:rPr lang="en-US" sz="3200" b="1" dirty="0">
+                <a:solidFill>
+                  <a:srgbClr val="FF7A3C"/>
+                </a:solidFill>
+                <a:latin typeface="Arial" pitchFamily="34" charset="0"/>
+                <a:ea typeface="Arial" pitchFamily="34" charset="-122"/>
+                <a:cs typeface="Arial" pitchFamily="34" charset="-120"/>
+              </a:rPr>
+              <a:t>مثال تطبيقي مقترح (ديمو 60 ثانية)</a:t>
+            </a:r>
+            <a:endParaRPr lang="en-US" sz="3200" dirty="0"/>
+          </a:p>
+        </p:txBody>
+      </p:sp>
+      <p:sp>
+        <p:nvSpPr>
+          <p:cNvPr id="3" name="Shape 1"/>
+          <p:cNvSpPr/>
+          <p:nvPr/>
+        </p:nvSpPr>
+        <p:spPr>
+          <a:xfrm>
+            <a:off x="640080" y="1554480"/>
+            <a:ext cx="10881360" cy="822960"/>
           </a:xfrm>
           <a:prstGeom prst="roundRect">
             <a:avLst>
-              <a:gd name="adj" fmla="val 7742"/>
+              <a:gd name="adj" fmla="val 13333"/>
             </a:avLst>
           </a:prstGeom>
           <a:solidFill>
@@ -3056,152 +3387,118 @@
       </p:sp>
       <p:sp>
         <p:nvSpPr>
-          <p:cNvPr id="14" name="Shape 12"/>
-          <p:cNvSpPr/>
-          <p:nvPr/>
-        </p:nvSpPr>
-        <p:spPr>
-          <a:xfrm>
-            <a:off x="5120640" y="3337560"/>
-            <a:ext cx="548640" cy="548640"/>
-          </a:xfrm>
-          <a:prstGeom prst="ellipse">
-            <a:avLst/>
-          </a:prstGeom>
-          <a:solidFill>
-            <a:srgbClr val="27305A"/>
-          </a:solidFill>
-          <a:ln/>
-        </p:spPr>
-      </p:sp>
-      <p:sp>
-        <p:nvSpPr>
-          <p:cNvPr id="15" name="Text 13"/>
-          <p:cNvSpPr/>
-          <p:nvPr/>
-        </p:nvSpPr>
-        <p:spPr>
-          <a:xfrm>
-            <a:off x="5120640" y="3337560"/>
-            <a:ext cx="548640" cy="548640"/>
-          </a:xfrm>
-          <a:prstGeom prst="rect">
-            <a:avLst/>
-          </a:prstGeom>
-          <a:noFill/>
-          <a:ln/>
-        </p:spPr>
-        <p:txBody>
-          <a:bodyPr wrap="square" lIns="0" tIns="0" rIns="0" bIns="0" rtlCol="0" anchor="ctr"/>
-          <a:lstStyle/>
-          <a:p>
-            <a:pPr algn="ctr" indent="0" marL="0">
-              <a:buNone/>
-            </a:pPr>
-            <a:r>
-              <a:rPr lang="en-US" sz="2200" dirty="0">
-                <a:solidFill>
-                  <a:srgbClr val="000000"/>
-                </a:solidFill>
-              </a:rPr>
-              <a:t>💬</a:t>
-            </a:r>
-            <a:endParaRPr lang="en-US" sz="2200" dirty="0"/>
-          </a:p>
-        </p:txBody>
-      </p:sp>
-      <p:sp>
-        <p:nvSpPr>
-          <p:cNvPr id="16" name="Text 14"/>
-          <p:cNvSpPr/>
-          <p:nvPr/>
-        </p:nvSpPr>
-        <p:spPr>
-          <a:xfrm>
-            <a:off x="914400" y="3310128"/>
-            <a:ext cx="4069080" cy="457200"/>
-          </a:xfrm>
-          <a:prstGeom prst="rect">
-            <a:avLst/>
-          </a:prstGeom>
-          <a:noFill/>
-          <a:ln/>
-        </p:spPr>
-        <p:txBody>
-          <a:bodyPr wrap="square" lIns="0" tIns="0" rIns="0" bIns="0" rtlCol="0" anchor="ctr"/>
-          <a:lstStyle/>
-          <a:p>
-            <a:pPr rtl="1" algn="r" indent="0" marL="0">
-              <a:buNone/>
-            </a:pPr>
-            <a:r>
-              <a:rPr lang="en-US" sz="1700" b="1" dirty="0">
-                <a:solidFill>
-                  <a:srgbClr val="EEF1FF"/>
-                </a:solidFill>
-                <a:latin typeface="Arial" pitchFamily="34" charset="0"/>
-                <a:ea typeface="Arial" pitchFamily="34" charset="-122"/>
-                <a:cs typeface="Arial" pitchFamily="34" charset="-120"/>
-              </a:rPr>
-              <a:t>رسالة التشجيع</a:t>
-            </a:r>
-            <a:endParaRPr lang="en-US" sz="1700" dirty="0"/>
-          </a:p>
-        </p:txBody>
-      </p:sp>
-      <p:sp>
-        <p:nvSpPr>
-          <p:cNvPr id="17" name="Text 15"/>
-          <p:cNvSpPr/>
-          <p:nvPr/>
-        </p:nvSpPr>
-        <p:spPr>
-          <a:xfrm>
-            <a:off x="914400" y="3767328"/>
-            <a:ext cx="4069080" cy="594360"/>
-          </a:xfrm>
-          <a:prstGeom prst="rect">
-            <a:avLst/>
-          </a:prstGeom>
-          <a:noFill/>
-          <a:ln/>
-        </p:spPr>
-        <p:txBody>
-          <a:bodyPr wrap="square" lIns="0" tIns="0" rIns="0" bIns="0" rtlCol="0" anchor="t"/>
-          <a:lstStyle/>
-          <a:p>
-            <a:pPr rtl="1" algn="r" indent="0" marL="0">
-              <a:buNone/>
-            </a:pPr>
-            <a:r>
-              <a:rPr lang="en-US" sz="1250" dirty="0">
-                <a:solidFill>
-                  <a:srgbClr val="A7ADCE"/>
-                </a:solidFill>
-                <a:latin typeface="Arial" pitchFamily="34" charset="0"/>
-                <a:ea typeface="Arial" pitchFamily="34" charset="-122"/>
-                <a:cs typeface="Arial" pitchFamily="34" charset="-120"/>
-              </a:rPr>
-              <a:t>داعمة لا موبّخة، حسب السياق.</a:t>
-            </a:r>
-            <a:endParaRPr lang="en-US" sz="1250" dirty="0"/>
-          </a:p>
-        </p:txBody>
-      </p:sp>
-      <p:sp>
-        <p:nvSpPr>
-          <p:cNvPr id="18" name="Shape 16"/>
-          <p:cNvSpPr/>
-          <p:nvPr/>
-        </p:nvSpPr>
-        <p:spPr>
-          <a:xfrm>
-            <a:off x="6172200" y="3108960"/>
-            <a:ext cx="5349240" cy="1417320"/>
+          <p:cNvPr id="4" name="Shape 2"/>
+          <p:cNvSpPr/>
+          <p:nvPr/>
+        </p:nvSpPr>
+        <p:spPr>
+          <a:xfrm>
+            <a:off x="10012680" y="1755648"/>
+            <a:ext cx="1371600" cy="420624"/>
           </a:xfrm>
           <a:prstGeom prst="roundRect">
             <a:avLst>
-              <a:gd name="adj" fmla="val 7742"/>
+              <a:gd name="adj" fmla="val 21739"/>
+            </a:avLst>
+          </a:prstGeom>
+          <a:solidFill>
+            <a:srgbClr val="FF7A3C"/>
+          </a:solidFill>
+          <a:ln/>
+        </p:spPr>
+      </p:sp>
+      <p:sp>
+        <p:nvSpPr>
+          <p:cNvPr id="5" name="Text 3"/>
+          <p:cNvSpPr/>
+          <p:nvPr/>
+        </p:nvSpPr>
+        <p:spPr>
+          <a:xfrm>
+            <a:off x="10012680" y="1755648"/>
+            <a:ext cx="1371600" cy="420624"/>
+          </a:xfrm>
+          <a:prstGeom prst="rect">
+            <a:avLst/>
+          </a:prstGeom>
+          <a:noFill/>
+          <a:ln/>
+        </p:spPr>
+        <p:txBody>
+          <a:bodyPr wrap="square" lIns="0" tIns="0" rIns="0" bIns="0" rtlCol="0" anchor="ctr"/>
+          <a:lstStyle/>
+          <a:p>
+            <a:pPr algn="ctr" indent="0" marL="0">
+              <a:buNone/>
+            </a:pPr>
+            <a:r>
+              <a:rPr lang="en-US" sz="1300" b="1" dirty="0">
+                <a:solidFill>
+                  <a:srgbClr val="141A33"/>
+                </a:solidFill>
+                <a:latin typeface="Arial" pitchFamily="34" charset="0"/>
+                <a:ea typeface="Arial" pitchFamily="34" charset="-122"/>
+                <a:cs typeface="Arial" pitchFamily="34" charset="-120"/>
+              </a:rPr>
+              <a:t>0:00–0:10</a:t>
+            </a:r>
+            <a:endParaRPr lang="en-US" sz="1300" dirty="0"/>
+          </a:p>
+        </p:txBody>
+      </p:sp>
+      <p:sp>
+        <p:nvSpPr>
+          <p:cNvPr id="6" name="Text 4"/>
+          <p:cNvSpPr/>
+          <p:nvPr/>
+        </p:nvSpPr>
+        <p:spPr>
+          <a:xfrm>
+            <a:off x="868680" y="1645920"/>
+            <a:ext cx="9006840" cy="640080"/>
+          </a:xfrm>
+          <a:prstGeom prst="rect">
+            <a:avLst/>
+          </a:prstGeom>
+          <a:noFill/>
+          <a:ln/>
+        </p:spPr>
+        <p:txBody>
+          <a:bodyPr wrap="square" lIns="0" tIns="0" rIns="0" bIns="0" rtlCol="0" anchor="ctr"/>
+          <a:lstStyle/>
+          <a:p>
+            <a:pPr rtl="1" algn="r" indent="0" marL="0">
+              <a:buNone/>
+            </a:pPr>
+            <a:r>
+              <a:rPr lang="en-US" sz="1400" dirty="0">
+                <a:solidFill>
+                  <a:srgbClr val="EEF1FF"/>
+                </a:solidFill>
+                <a:latin typeface="Arial" pitchFamily="34" charset="0"/>
+                <a:ea typeface="Arial" pitchFamily="34" charset="-122"/>
+                <a:cs typeface="Arial" pitchFamily="34" charset="-120"/>
+              </a:rPr>
+              <a:t>الأب يسجّل، ينشئ ملف «سامي»، ويشتري 500 Robux → تُقفل في الخزنة 🔒</a:t>
+            </a:r>
+            <a:endParaRPr lang="en-US" sz="1400" dirty="0"/>
+          </a:p>
+        </p:txBody>
+      </p:sp>
+      <p:sp>
+        <p:nvSpPr>
+          <p:cNvPr id="7" name="Shape 5"/>
+          <p:cNvSpPr/>
+          <p:nvPr/>
+        </p:nvSpPr>
+        <p:spPr>
+          <a:xfrm>
+            <a:off x="640080" y="2450592"/>
+            <a:ext cx="10881360" cy="822960"/>
+          </a:xfrm>
+          <a:prstGeom prst="roundRect">
+            <a:avLst>
+              <a:gd name="adj" fmla="val 13333"/>
             </a:avLst>
           </a:prstGeom>
           <a:solidFill>
@@ -3224,6 +3521,1156 @@
       </p:sp>
       <p:sp>
         <p:nvSpPr>
+          <p:cNvPr id="8" name="Shape 6"/>
+          <p:cNvSpPr/>
+          <p:nvPr/>
+        </p:nvSpPr>
+        <p:spPr>
+          <a:xfrm>
+            <a:off x="10012680" y="2651760"/>
+            <a:ext cx="1371600" cy="420624"/>
+          </a:xfrm>
+          <a:prstGeom prst="roundRect">
+            <a:avLst>
+              <a:gd name="adj" fmla="val 21739"/>
+            </a:avLst>
+          </a:prstGeom>
+          <a:solidFill>
+            <a:srgbClr val="FF7A3C"/>
+          </a:solidFill>
+          <a:ln/>
+        </p:spPr>
+      </p:sp>
+      <p:sp>
+        <p:nvSpPr>
+          <p:cNvPr id="9" name="Text 7"/>
+          <p:cNvSpPr/>
+          <p:nvPr/>
+        </p:nvSpPr>
+        <p:spPr>
+          <a:xfrm>
+            <a:off x="10012680" y="2651760"/>
+            <a:ext cx="1371600" cy="420624"/>
+          </a:xfrm>
+          <a:prstGeom prst="rect">
+            <a:avLst/>
+          </a:prstGeom>
+          <a:noFill/>
+          <a:ln/>
+        </p:spPr>
+        <p:txBody>
+          <a:bodyPr wrap="square" lIns="0" tIns="0" rIns="0" bIns="0" rtlCol="0" anchor="ctr"/>
+          <a:lstStyle/>
+          <a:p>
+            <a:pPr algn="ctr" indent="0" marL="0">
+              <a:buNone/>
+            </a:pPr>
+            <a:r>
+              <a:rPr lang="en-US" sz="1300" b="1" dirty="0">
+                <a:solidFill>
+                  <a:srgbClr val="141A33"/>
+                </a:solidFill>
+                <a:latin typeface="Arial" pitchFamily="34" charset="0"/>
+                <a:ea typeface="Arial" pitchFamily="34" charset="-122"/>
+                <a:cs typeface="Arial" pitchFamily="34" charset="-120"/>
+              </a:rPr>
+              <a:t>0:10–0:20</a:t>
+            </a:r>
+            <a:endParaRPr lang="en-US" sz="1300" dirty="0"/>
+          </a:p>
+        </p:txBody>
+      </p:sp>
+      <p:sp>
+        <p:nvSpPr>
+          <p:cNvPr id="10" name="Text 8"/>
+          <p:cNvSpPr/>
+          <p:nvPr/>
+        </p:nvSpPr>
+        <p:spPr>
+          <a:xfrm>
+            <a:off x="868680" y="2542032"/>
+            <a:ext cx="9006840" cy="640080"/>
+          </a:xfrm>
+          <a:prstGeom prst="rect">
+            <a:avLst/>
+          </a:prstGeom>
+          <a:noFill/>
+          <a:ln/>
+        </p:spPr>
+        <p:txBody>
+          <a:bodyPr wrap="square" lIns="0" tIns="0" rIns="0" bIns="0" rtlCol="0" anchor="ctr"/>
+          <a:lstStyle/>
+          <a:p>
+            <a:pPr rtl="1" algn="r" indent="0" marL="0">
+              <a:buNone/>
+            </a:pPr>
+            <a:r>
+              <a:rPr lang="en-US" sz="1400" dirty="0">
+                <a:solidFill>
+                  <a:srgbClr val="EEF1FF"/>
+                </a:solidFill>
+                <a:latin typeface="Arial" pitchFamily="34" charset="0"/>
+                <a:ea typeface="Arial" pitchFamily="34" charset="-122"/>
+                <a:cs typeface="Arial" pitchFamily="34" charset="-120"/>
+              </a:rPr>
+              <a:t>الأب يسلّم الجهاز؛ سامي يدخل بـ PIN → خريطة فيها 3 وحوش وخزنة 0%</a:t>
+            </a:r>
+            <a:endParaRPr lang="en-US" sz="1400" dirty="0"/>
+          </a:p>
+        </p:txBody>
+      </p:sp>
+      <p:sp>
+        <p:nvSpPr>
+          <p:cNvPr id="11" name="Shape 9"/>
+          <p:cNvSpPr/>
+          <p:nvPr/>
+        </p:nvSpPr>
+        <p:spPr>
+          <a:xfrm>
+            <a:off x="640080" y="3346704"/>
+            <a:ext cx="10881360" cy="822960"/>
+          </a:xfrm>
+          <a:prstGeom prst="roundRect">
+            <a:avLst>
+              <a:gd name="adj" fmla="val 13333"/>
+            </a:avLst>
+          </a:prstGeom>
+          <a:solidFill>
+            <a:srgbClr val="1F2748"/>
+          </a:solidFill>
+          <a:ln w="12700">
+            <a:solidFill>
+              <a:srgbClr val="27305A"/>
+            </a:solidFill>
+            <a:prstDash val="solid"/>
+          </a:ln>
+          <a:effectLst>
+            <a:outerShdw sx="100000" sy="100000" kx="0" ky="0" algn="bl" rotWithShape="0" blurRad="101600" dist="38100" dir="5400000">
+              <a:srgbClr val="0A0E20">
+                <a:alpha val="50000"/>
+              </a:srgbClr>
+            </a:outerShdw>
+          </a:effectLst>
+        </p:spPr>
+      </p:sp>
+      <p:sp>
+        <p:nvSpPr>
+          <p:cNvPr id="12" name="Shape 10"/>
+          <p:cNvSpPr/>
+          <p:nvPr/>
+        </p:nvSpPr>
+        <p:spPr>
+          <a:xfrm>
+            <a:off x="10012680" y="3547872"/>
+            <a:ext cx="1371600" cy="420624"/>
+          </a:xfrm>
+          <a:prstGeom prst="roundRect">
+            <a:avLst>
+              <a:gd name="adj" fmla="val 21739"/>
+            </a:avLst>
+          </a:prstGeom>
+          <a:solidFill>
+            <a:srgbClr val="FF7A3C"/>
+          </a:solidFill>
+          <a:ln/>
+        </p:spPr>
+      </p:sp>
+      <p:sp>
+        <p:nvSpPr>
+          <p:cNvPr id="13" name="Text 11"/>
+          <p:cNvSpPr/>
+          <p:nvPr/>
+        </p:nvSpPr>
+        <p:spPr>
+          <a:xfrm>
+            <a:off x="10012680" y="3547872"/>
+            <a:ext cx="1371600" cy="420624"/>
+          </a:xfrm>
+          <a:prstGeom prst="rect">
+            <a:avLst/>
+          </a:prstGeom>
+          <a:noFill/>
+          <a:ln/>
+        </p:spPr>
+        <p:txBody>
+          <a:bodyPr wrap="square" lIns="0" tIns="0" rIns="0" bIns="0" rtlCol="0" anchor="ctr"/>
+          <a:lstStyle/>
+          <a:p>
+            <a:pPr algn="ctr" indent="0" marL="0">
+              <a:buNone/>
+            </a:pPr>
+            <a:r>
+              <a:rPr lang="en-US" sz="1300" b="1" dirty="0">
+                <a:solidFill>
+                  <a:srgbClr val="141A33"/>
+                </a:solidFill>
+                <a:latin typeface="Arial" pitchFamily="34" charset="0"/>
+                <a:ea typeface="Arial" pitchFamily="34" charset="-122"/>
+                <a:cs typeface="Arial" pitchFamily="34" charset="-120"/>
+              </a:rPr>
+              <a:t>0:20–0:40</a:t>
+            </a:r>
+            <a:endParaRPr lang="en-US" sz="1300" dirty="0"/>
+          </a:p>
+        </p:txBody>
+      </p:sp>
+      <p:sp>
+        <p:nvSpPr>
+          <p:cNvPr id="14" name="Text 12"/>
+          <p:cNvSpPr/>
+          <p:nvPr/>
+        </p:nvSpPr>
+        <p:spPr>
+          <a:xfrm>
+            <a:off x="868680" y="3438144"/>
+            <a:ext cx="9006840" cy="640080"/>
+          </a:xfrm>
+          <a:prstGeom prst="rect">
+            <a:avLst/>
+          </a:prstGeom>
+          <a:noFill/>
+          <a:ln/>
+        </p:spPr>
+        <p:txBody>
+          <a:bodyPr wrap="square" lIns="0" tIns="0" rIns="0" bIns="0" rtlCol="0" anchor="ctr"/>
+          <a:lstStyle/>
+          <a:p>
+            <a:pPr rtl="1" algn="r" indent="0" marL="0">
+              <a:buNone/>
+            </a:pPr>
+            <a:r>
+              <a:rPr lang="en-US" sz="1400" dirty="0">
+                <a:solidFill>
+                  <a:srgbClr val="EEF1FF"/>
+                </a:solidFill>
+                <a:latin typeface="Arial" pitchFamily="34" charset="0"/>
+                <a:ea typeface="Arial" pitchFamily="34" charset="-122"/>
+                <a:cs typeface="Arial" pitchFamily="34" charset="-120"/>
+              </a:rPr>
+              <a:t>يواجه وحش الشراء السريع → يختار «أنتظر وأفكّر» → يهزمه، الخزنة 33%، رسالة تشجيع، والـ AI يقترح الوحش التالي</a:t>
+            </a:r>
+            <a:endParaRPr lang="en-US" sz="1400" dirty="0"/>
+          </a:p>
+        </p:txBody>
+      </p:sp>
+      <p:sp>
+        <p:nvSpPr>
+          <p:cNvPr id="15" name="Shape 13"/>
+          <p:cNvSpPr/>
+          <p:nvPr/>
+        </p:nvSpPr>
+        <p:spPr>
+          <a:xfrm>
+            <a:off x="640080" y="4242816"/>
+            <a:ext cx="10881360" cy="822960"/>
+          </a:xfrm>
+          <a:prstGeom prst="roundRect">
+            <a:avLst>
+              <a:gd name="adj" fmla="val 13333"/>
+            </a:avLst>
+          </a:prstGeom>
+          <a:solidFill>
+            <a:srgbClr val="1F2748"/>
+          </a:solidFill>
+          <a:ln w="12700">
+            <a:solidFill>
+              <a:srgbClr val="27305A"/>
+            </a:solidFill>
+            <a:prstDash val="solid"/>
+          </a:ln>
+          <a:effectLst>
+            <a:outerShdw sx="100000" sy="100000" kx="0" ky="0" algn="bl" rotWithShape="0" blurRad="101600" dist="38100" dir="5400000">
+              <a:srgbClr val="0A0E20">
+                <a:alpha val="50000"/>
+              </a:srgbClr>
+            </a:outerShdw>
+          </a:effectLst>
+        </p:spPr>
+      </p:sp>
+      <p:sp>
+        <p:nvSpPr>
+          <p:cNvPr id="16" name="Shape 14"/>
+          <p:cNvSpPr/>
+          <p:nvPr/>
+        </p:nvSpPr>
+        <p:spPr>
+          <a:xfrm>
+            <a:off x="10012680" y="4443984"/>
+            <a:ext cx="1371600" cy="420624"/>
+          </a:xfrm>
+          <a:prstGeom prst="roundRect">
+            <a:avLst>
+              <a:gd name="adj" fmla="val 21739"/>
+            </a:avLst>
+          </a:prstGeom>
+          <a:solidFill>
+            <a:srgbClr val="FF7A3C"/>
+          </a:solidFill>
+          <a:ln/>
+        </p:spPr>
+      </p:sp>
+      <p:sp>
+        <p:nvSpPr>
+          <p:cNvPr id="17" name="Text 15"/>
+          <p:cNvSpPr/>
+          <p:nvPr/>
+        </p:nvSpPr>
+        <p:spPr>
+          <a:xfrm>
+            <a:off x="10012680" y="4443984"/>
+            <a:ext cx="1371600" cy="420624"/>
+          </a:xfrm>
+          <a:prstGeom prst="rect">
+            <a:avLst/>
+          </a:prstGeom>
+          <a:noFill/>
+          <a:ln/>
+        </p:spPr>
+        <p:txBody>
+          <a:bodyPr wrap="square" lIns="0" tIns="0" rIns="0" bIns="0" rtlCol="0" anchor="ctr"/>
+          <a:lstStyle/>
+          <a:p>
+            <a:pPr algn="ctr" indent="0" marL="0">
+              <a:buNone/>
+            </a:pPr>
+            <a:r>
+              <a:rPr lang="en-US" sz="1300" b="1" dirty="0">
+                <a:solidFill>
+                  <a:srgbClr val="141A33"/>
+                </a:solidFill>
+                <a:latin typeface="Arial" pitchFamily="34" charset="0"/>
+                <a:ea typeface="Arial" pitchFamily="34" charset="-122"/>
+                <a:cs typeface="Arial" pitchFamily="34" charset="-120"/>
+              </a:rPr>
+              <a:t>0:40–0:55</a:t>
+            </a:r>
+            <a:endParaRPr lang="en-US" sz="1300" dirty="0"/>
+          </a:p>
+        </p:txBody>
+      </p:sp>
+      <p:sp>
+        <p:nvSpPr>
+          <p:cNvPr id="18" name="Text 16"/>
+          <p:cNvSpPr/>
+          <p:nvPr/>
+        </p:nvSpPr>
+        <p:spPr>
+          <a:xfrm>
+            <a:off x="868680" y="4334256"/>
+            <a:ext cx="9006840" cy="640080"/>
+          </a:xfrm>
+          <a:prstGeom prst="rect">
+            <a:avLst/>
+          </a:prstGeom>
+          <a:noFill/>
+          <a:ln/>
+        </p:spPr>
+        <p:txBody>
+          <a:bodyPr wrap="square" lIns="0" tIns="0" rIns="0" bIns="0" rtlCol="0" anchor="ctr"/>
+          <a:lstStyle/>
+          <a:p>
+            <a:pPr rtl="1" algn="r" indent="0" marL="0">
+              <a:buNone/>
+            </a:pPr>
+            <a:r>
+              <a:rPr lang="en-US" sz="1400" dirty="0">
+                <a:solidFill>
+                  <a:srgbClr val="EEF1FF"/>
+                </a:solidFill>
+                <a:latin typeface="Arial" pitchFamily="34" charset="0"/>
+                <a:ea typeface="Arial" pitchFamily="34" charset="-122"/>
+                <a:cs typeface="Arial" pitchFamily="34" charset="-120"/>
+              </a:rPr>
+              <a:t>يهزم ضغط الأصدقاء (67%) ثم العروض الوهمية النهائي (100%) → احتفال وفتح 500 Robux</a:t>
+            </a:r>
+            <a:endParaRPr lang="en-US" sz="1400" dirty="0"/>
+          </a:p>
+        </p:txBody>
+      </p:sp>
+      <p:sp>
+        <p:nvSpPr>
+          <p:cNvPr id="19" name="Shape 17"/>
+          <p:cNvSpPr/>
+          <p:nvPr/>
+        </p:nvSpPr>
+        <p:spPr>
+          <a:xfrm>
+            <a:off x="640080" y="5138928"/>
+            <a:ext cx="10881360" cy="822960"/>
+          </a:xfrm>
+          <a:prstGeom prst="roundRect">
+            <a:avLst>
+              <a:gd name="adj" fmla="val 13333"/>
+            </a:avLst>
+          </a:prstGeom>
+          <a:solidFill>
+            <a:srgbClr val="1F2748"/>
+          </a:solidFill>
+          <a:ln w="12700">
+            <a:solidFill>
+              <a:srgbClr val="27305A"/>
+            </a:solidFill>
+            <a:prstDash val="solid"/>
+          </a:ln>
+          <a:effectLst>
+            <a:outerShdw sx="100000" sy="100000" kx="0" ky="0" algn="bl" rotWithShape="0" blurRad="101600" dist="38100" dir="5400000">
+              <a:srgbClr val="0A0E20">
+                <a:alpha val="50000"/>
+              </a:srgbClr>
+            </a:outerShdw>
+          </a:effectLst>
+        </p:spPr>
+      </p:sp>
+      <p:sp>
+        <p:nvSpPr>
+          <p:cNvPr id="20" name="Shape 18"/>
+          <p:cNvSpPr/>
+          <p:nvPr/>
+        </p:nvSpPr>
+        <p:spPr>
+          <a:xfrm>
+            <a:off x="10012680" y="5340096"/>
+            <a:ext cx="1371600" cy="420624"/>
+          </a:xfrm>
+          <a:prstGeom prst="roundRect">
+            <a:avLst>
+              <a:gd name="adj" fmla="val 21739"/>
+            </a:avLst>
+          </a:prstGeom>
+          <a:solidFill>
+            <a:srgbClr val="FF7A3C"/>
+          </a:solidFill>
+          <a:ln/>
+        </p:spPr>
+      </p:sp>
+      <p:sp>
+        <p:nvSpPr>
+          <p:cNvPr id="21" name="Text 19"/>
+          <p:cNvSpPr/>
+          <p:nvPr/>
+        </p:nvSpPr>
+        <p:spPr>
+          <a:xfrm>
+            <a:off x="10012680" y="5340096"/>
+            <a:ext cx="1371600" cy="420624"/>
+          </a:xfrm>
+          <a:prstGeom prst="rect">
+            <a:avLst/>
+          </a:prstGeom>
+          <a:noFill/>
+          <a:ln/>
+        </p:spPr>
+        <p:txBody>
+          <a:bodyPr wrap="square" lIns="0" tIns="0" rIns="0" bIns="0" rtlCol="0" anchor="ctr"/>
+          <a:lstStyle/>
+          <a:p>
+            <a:pPr algn="ctr" indent="0" marL="0">
+              <a:buNone/>
+            </a:pPr>
+            <a:r>
+              <a:rPr lang="en-US" sz="1300" b="1" dirty="0">
+                <a:solidFill>
+                  <a:srgbClr val="141A33"/>
+                </a:solidFill>
+                <a:latin typeface="Arial" pitchFamily="34" charset="0"/>
+                <a:ea typeface="Arial" pitchFamily="34" charset="-122"/>
+                <a:cs typeface="Arial" pitchFamily="34" charset="-120"/>
+              </a:rPr>
+              <a:t>0:55–1:00</a:t>
+            </a:r>
+            <a:endParaRPr lang="en-US" sz="1300" dirty="0"/>
+          </a:p>
+        </p:txBody>
+      </p:sp>
+      <p:sp>
+        <p:nvSpPr>
+          <p:cNvPr id="22" name="Text 20"/>
+          <p:cNvSpPr/>
+          <p:nvPr/>
+        </p:nvSpPr>
+        <p:spPr>
+          <a:xfrm>
+            <a:off x="868680" y="5230368"/>
+            <a:ext cx="9006840" cy="640080"/>
+          </a:xfrm>
+          <a:prstGeom prst="rect">
+            <a:avLst/>
+          </a:prstGeom>
+          <a:noFill/>
+          <a:ln/>
+        </p:spPr>
+        <p:txBody>
+          <a:bodyPr wrap="square" lIns="0" tIns="0" rIns="0" bIns="0" rtlCol="0" anchor="ctr"/>
+          <a:lstStyle/>
+          <a:p>
+            <a:pPr rtl="1" algn="r" indent="0" marL="0">
+              <a:buNone/>
+            </a:pPr>
+            <a:r>
+              <a:rPr lang="en-US" sz="1400" dirty="0">
+                <a:solidFill>
+                  <a:srgbClr val="EEF1FF"/>
+                </a:solidFill>
+                <a:latin typeface="Arial" pitchFamily="34" charset="0"/>
+                <a:ea typeface="Arial" pitchFamily="34" charset="-122"/>
+                <a:cs typeface="Arial" pitchFamily="34" charset="-120"/>
+              </a:rPr>
+              <a:t>الأب يفتح لوحة الرؤى: نمو الصبر وضبط الاندفاع + توقّع الإكمال</a:t>
+            </a:r>
+            <a:endParaRPr lang="en-US" sz="1400" dirty="0"/>
+          </a:p>
+        </p:txBody>
+      </p:sp>
+      <p:sp>
+        <p:nvSpPr>
+          <p:cNvPr id="23" name="Text 21"/>
+          <p:cNvSpPr/>
+          <p:nvPr/>
+        </p:nvSpPr>
+        <p:spPr>
+          <a:xfrm>
+            <a:off x="548640" y="6309360"/>
+            <a:ext cx="11064240" cy="365760"/>
+          </a:xfrm>
+          <a:prstGeom prst="rect">
+            <a:avLst/>
+          </a:prstGeom>
+          <a:noFill/>
+          <a:ln/>
+        </p:spPr>
+        <p:txBody>
+          <a:bodyPr wrap="square" lIns="0" tIns="0" rIns="0" bIns="0" rtlCol="0" anchor="ctr"/>
+          <a:lstStyle/>
+          <a:p>
+            <a:pPr rtl="1" algn="r" indent="0" marL="0">
+              <a:buNone/>
+            </a:pPr>
+            <a:r>
+              <a:rPr lang="en-US" sz="1100" i="1" dirty="0">
+                <a:solidFill>
+                  <a:srgbClr val="A7ADCE"/>
+                </a:solidFill>
+                <a:latin typeface="Arial" pitchFamily="34" charset="0"/>
+                <a:ea typeface="Arial" pitchFamily="34" charset="-122"/>
+                <a:cs typeface="Arial" pitchFamily="34" charset="-120"/>
+              </a:rPr>
+              <a:t>الغرض: إثبات فعالية النموذج (تعلّم + متعة + فتح تدريجي) قبل الإطلاق.</a:t>
+            </a:r>
+            <a:endParaRPr lang="en-US" sz="1100" dirty="0"/>
+          </a:p>
+        </p:txBody>
+      </p:sp>
+    </p:spTree>
+  </p:cSld>
+  <p:clrMapOvr>
+    <a:masterClrMapping/>
+  </p:clrMapOvr>
+</p:sld>
+</file>
+
+<file path=ppt/slides/slide13.xml><?xml version="1.0" encoding="utf-8"?>
+<p:sld xmlns:a="http://schemas.openxmlformats.org/drawingml/2006/main" xmlns:r="http://schemas.openxmlformats.org/officeDocument/2006/relationships" xmlns:p="http://schemas.openxmlformats.org/presentationml/2006/main">
+  <p:cSld name="Slide 13">
+    <p:bg>
+      <p:bgPr>
+        <a:solidFill>
+          <a:srgbClr val="141A33"/>
+        </a:solidFill>
+      </p:bgPr>
+    </p:bg>
+    <p:spTree>
+      <p:nvGrpSpPr>
+        <p:cNvPr id="1" name=""/>
+        <p:cNvGrpSpPr/>
+        <p:nvPr/>
+      </p:nvGrpSpPr>
+      <p:grpSpPr>
+        <a:xfrm>
+          <a:off x="0" y="0"/>
+          <a:ext cx="0" cy="0"/>
+          <a:chOff x="0" y="0"/>
+          <a:chExt cx="0" cy="0"/>
+        </a:xfrm>
+      </p:grpSpPr>
+      <p:sp>
+        <p:nvSpPr>
+          <p:cNvPr id="2" name="Text 0"/>
+          <p:cNvSpPr/>
+          <p:nvPr/>
+        </p:nvSpPr>
+        <p:spPr>
+          <a:xfrm>
+            <a:off x="548640" y="365760"/>
+            <a:ext cx="11064240" cy="822960"/>
+          </a:xfrm>
+          <a:prstGeom prst="rect">
+            <a:avLst/>
+          </a:prstGeom>
+          <a:noFill/>
+          <a:ln/>
+        </p:spPr>
+        <p:txBody>
+          <a:bodyPr wrap="square" rtlCol="0" anchor="ctr"/>
+          <a:lstStyle/>
+          <a:p>
+            <a:pPr rtl="1" algn="r" indent="0" marL="0">
+              <a:buNone/>
+            </a:pPr>
+            <a:r>
+              <a:rPr lang="en-US" sz="3200" b="1" dirty="0">
+                <a:solidFill>
+                  <a:srgbClr val="FF7A3C"/>
+                </a:solidFill>
+                <a:latin typeface="Arial" pitchFamily="34" charset="0"/>
+                <a:ea typeface="Arial" pitchFamily="34" charset="-122"/>
+                <a:cs typeface="Arial" pitchFamily="34" charset="-120"/>
+              </a:rPr>
+              <a:t>الذكاء الاصطناعي (rule-engine → ML)</a:t>
+            </a:r>
+            <a:endParaRPr lang="en-US" sz="3200" dirty="0"/>
+          </a:p>
+        </p:txBody>
+      </p:sp>
+      <p:sp>
+        <p:nvSpPr>
+          <p:cNvPr id="3" name="Shape 1"/>
+          <p:cNvSpPr/>
+          <p:nvPr/>
+        </p:nvSpPr>
+        <p:spPr>
+          <a:xfrm>
+            <a:off x="640080" y="1554480"/>
+            <a:ext cx="5349240" cy="1417320"/>
+          </a:xfrm>
+          <a:prstGeom prst="roundRect">
+            <a:avLst>
+              <a:gd name="adj" fmla="val 7742"/>
+            </a:avLst>
+          </a:prstGeom>
+          <a:solidFill>
+            <a:srgbClr val="1F2748"/>
+          </a:solidFill>
+          <a:ln w="12700">
+            <a:solidFill>
+              <a:srgbClr val="27305A"/>
+            </a:solidFill>
+            <a:prstDash val="solid"/>
+          </a:ln>
+          <a:effectLst>
+            <a:outerShdw sx="100000" sy="100000" kx="0" ky="0" algn="bl" rotWithShape="0" blurRad="101600" dist="38100" dir="5400000">
+              <a:srgbClr val="0A0E20">
+                <a:alpha val="50000"/>
+              </a:srgbClr>
+            </a:outerShdw>
+          </a:effectLst>
+        </p:spPr>
+      </p:sp>
+      <p:sp>
+        <p:nvSpPr>
+          <p:cNvPr id="4" name="Shape 2"/>
+          <p:cNvSpPr/>
+          <p:nvPr/>
+        </p:nvSpPr>
+        <p:spPr>
+          <a:xfrm>
+            <a:off x="5120640" y="1783080"/>
+            <a:ext cx="548640" cy="548640"/>
+          </a:xfrm>
+          <a:prstGeom prst="ellipse">
+            <a:avLst/>
+          </a:prstGeom>
+          <a:solidFill>
+            <a:srgbClr val="27305A"/>
+          </a:solidFill>
+          <a:ln/>
+        </p:spPr>
+      </p:sp>
+      <p:sp>
+        <p:nvSpPr>
+          <p:cNvPr id="5" name="Text 3"/>
+          <p:cNvSpPr/>
+          <p:nvPr/>
+        </p:nvSpPr>
+        <p:spPr>
+          <a:xfrm>
+            <a:off x="5120640" y="1783080"/>
+            <a:ext cx="548640" cy="548640"/>
+          </a:xfrm>
+          <a:prstGeom prst="rect">
+            <a:avLst/>
+          </a:prstGeom>
+          <a:noFill/>
+          <a:ln/>
+        </p:spPr>
+        <p:txBody>
+          <a:bodyPr wrap="square" lIns="0" tIns="0" rIns="0" bIns="0" rtlCol="0" anchor="ctr"/>
+          <a:lstStyle/>
+          <a:p>
+            <a:pPr algn="ctr" indent="0" marL="0">
+              <a:buNone/>
+            </a:pPr>
+            <a:r>
+              <a:rPr lang="en-US" sz="2200" dirty="0">
+                <a:solidFill>
+                  <a:srgbClr val="000000"/>
+                </a:solidFill>
+              </a:rPr>
+              <a:t>🎯</a:t>
+            </a:r>
+            <a:endParaRPr lang="en-US" sz="2200" dirty="0"/>
+          </a:p>
+        </p:txBody>
+      </p:sp>
+      <p:sp>
+        <p:nvSpPr>
+          <p:cNvPr id="6" name="Text 4"/>
+          <p:cNvSpPr/>
+          <p:nvPr/>
+        </p:nvSpPr>
+        <p:spPr>
+          <a:xfrm>
+            <a:off x="914400" y="1755648"/>
+            <a:ext cx="4069080" cy="457200"/>
+          </a:xfrm>
+          <a:prstGeom prst="rect">
+            <a:avLst/>
+          </a:prstGeom>
+          <a:noFill/>
+          <a:ln/>
+        </p:spPr>
+        <p:txBody>
+          <a:bodyPr wrap="square" lIns="0" tIns="0" rIns="0" bIns="0" rtlCol="0" anchor="ctr"/>
+          <a:lstStyle/>
+          <a:p>
+            <a:pPr rtl="1" algn="r" indent="0" marL="0">
+              <a:buNone/>
+            </a:pPr>
+            <a:r>
+              <a:rPr lang="en-US" sz="1700" b="1" dirty="0">
+                <a:solidFill>
+                  <a:srgbClr val="EEF1FF"/>
+                </a:solidFill>
+                <a:latin typeface="Arial" pitchFamily="34" charset="0"/>
+                <a:ea typeface="Arial" pitchFamily="34" charset="-122"/>
+                <a:cs typeface="Arial" pitchFamily="34" charset="-120"/>
+              </a:rPr>
+              <a:t>اختيار الوحش</a:t>
+            </a:r>
+            <a:endParaRPr lang="en-US" sz="1700" dirty="0"/>
+          </a:p>
+        </p:txBody>
+      </p:sp>
+      <p:sp>
+        <p:nvSpPr>
+          <p:cNvPr id="7" name="Text 5"/>
+          <p:cNvSpPr/>
+          <p:nvPr/>
+        </p:nvSpPr>
+        <p:spPr>
+          <a:xfrm>
+            <a:off x="914400" y="2212848"/>
+            <a:ext cx="4069080" cy="594360"/>
+          </a:xfrm>
+          <a:prstGeom prst="rect">
+            <a:avLst/>
+          </a:prstGeom>
+          <a:noFill/>
+          <a:ln/>
+        </p:spPr>
+        <p:txBody>
+          <a:bodyPr wrap="square" lIns="0" tIns="0" rIns="0" bIns="0" rtlCol="0" anchor="t"/>
+          <a:lstStyle/>
+          <a:p>
+            <a:pPr rtl="1" algn="r" indent="0" marL="0">
+              <a:buNone/>
+            </a:pPr>
+            <a:r>
+              <a:rPr lang="en-US" sz="1250" dirty="0">
+                <a:solidFill>
+                  <a:srgbClr val="A7ADCE"/>
+                </a:solidFill>
+                <a:latin typeface="Arial" pitchFamily="34" charset="0"/>
+                <a:ea typeface="Arial" pitchFamily="34" charset="-122"/>
+                <a:cs typeface="Arial" pitchFamily="34" charset="-120"/>
+              </a:rPr>
+              <a:t>يستهدف أضعف مهارة لدى الطفل.</a:t>
+            </a:r>
+            <a:endParaRPr lang="en-US" sz="1250" dirty="0"/>
+          </a:p>
+        </p:txBody>
+      </p:sp>
+      <p:sp>
+        <p:nvSpPr>
+          <p:cNvPr id="8" name="Shape 6"/>
+          <p:cNvSpPr/>
+          <p:nvPr/>
+        </p:nvSpPr>
+        <p:spPr>
+          <a:xfrm>
+            <a:off x="6172200" y="1554480"/>
+            <a:ext cx="5349240" cy="1417320"/>
+          </a:xfrm>
+          <a:prstGeom prst="roundRect">
+            <a:avLst>
+              <a:gd name="adj" fmla="val 7742"/>
+            </a:avLst>
+          </a:prstGeom>
+          <a:solidFill>
+            <a:srgbClr val="1F2748"/>
+          </a:solidFill>
+          <a:ln w="12700">
+            <a:solidFill>
+              <a:srgbClr val="27305A"/>
+            </a:solidFill>
+            <a:prstDash val="solid"/>
+          </a:ln>
+          <a:effectLst>
+            <a:outerShdw sx="100000" sy="100000" kx="0" ky="0" algn="bl" rotWithShape="0" blurRad="101600" dist="38100" dir="5400000">
+              <a:srgbClr val="0A0E20">
+                <a:alpha val="50000"/>
+              </a:srgbClr>
+            </a:outerShdw>
+          </a:effectLst>
+        </p:spPr>
+      </p:sp>
+      <p:sp>
+        <p:nvSpPr>
+          <p:cNvPr id="9" name="Shape 7"/>
+          <p:cNvSpPr/>
+          <p:nvPr/>
+        </p:nvSpPr>
+        <p:spPr>
+          <a:xfrm>
+            <a:off x="10652760" y="1783080"/>
+            <a:ext cx="548640" cy="548640"/>
+          </a:xfrm>
+          <a:prstGeom prst="ellipse">
+            <a:avLst/>
+          </a:prstGeom>
+          <a:solidFill>
+            <a:srgbClr val="27305A"/>
+          </a:solidFill>
+          <a:ln/>
+        </p:spPr>
+      </p:sp>
+      <p:sp>
+        <p:nvSpPr>
+          <p:cNvPr id="10" name="Text 8"/>
+          <p:cNvSpPr/>
+          <p:nvPr/>
+        </p:nvSpPr>
+        <p:spPr>
+          <a:xfrm>
+            <a:off x="10652760" y="1783080"/>
+            <a:ext cx="548640" cy="548640"/>
+          </a:xfrm>
+          <a:prstGeom prst="rect">
+            <a:avLst/>
+          </a:prstGeom>
+          <a:noFill/>
+          <a:ln/>
+        </p:spPr>
+        <p:txBody>
+          <a:bodyPr wrap="square" lIns="0" tIns="0" rIns="0" bIns="0" rtlCol="0" anchor="ctr"/>
+          <a:lstStyle/>
+          <a:p>
+            <a:pPr algn="ctr" indent="0" marL="0">
+              <a:buNone/>
+            </a:pPr>
+            <a:r>
+              <a:rPr lang="en-US" sz="2200" dirty="0">
+                <a:solidFill>
+                  <a:srgbClr val="000000"/>
+                </a:solidFill>
+              </a:rPr>
+              <a:t>⚖️</a:t>
+            </a:r>
+            <a:endParaRPr lang="en-US" sz="2200" dirty="0"/>
+          </a:p>
+        </p:txBody>
+      </p:sp>
+      <p:sp>
+        <p:nvSpPr>
+          <p:cNvPr id="11" name="Text 9"/>
+          <p:cNvSpPr/>
+          <p:nvPr/>
+        </p:nvSpPr>
+        <p:spPr>
+          <a:xfrm>
+            <a:off x="6446520" y="1755648"/>
+            <a:ext cx="4069080" cy="457200"/>
+          </a:xfrm>
+          <a:prstGeom prst="rect">
+            <a:avLst/>
+          </a:prstGeom>
+          <a:noFill/>
+          <a:ln/>
+        </p:spPr>
+        <p:txBody>
+          <a:bodyPr wrap="square" lIns="0" tIns="0" rIns="0" bIns="0" rtlCol="0" anchor="ctr"/>
+          <a:lstStyle/>
+          <a:p>
+            <a:pPr rtl="1" algn="r" indent="0" marL="0">
+              <a:buNone/>
+            </a:pPr>
+            <a:r>
+              <a:rPr lang="en-US" sz="1700" b="1" dirty="0">
+                <a:solidFill>
+                  <a:srgbClr val="EEF1FF"/>
+                </a:solidFill>
+                <a:latin typeface="Arial" pitchFamily="34" charset="0"/>
+                <a:ea typeface="Arial" pitchFamily="34" charset="-122"/>
+                <a:cs typeface="Arial" pitchFamily="34" charset="-120"/>
+              </a:rPr>
+              <a:t>تعديل الصعوبة</a:t>
+            </a:r>
+            <a:endParaRPr lang="en-US" sz="1700" dirty="0"/>
+          </a:p>
+        </p:txBody>
+      </p:sp>
+      <p:sp>
+        <p:nvSpPr>
+          <p:cNvPr id="12" name="Text 10"/>
+          <p:cNvSpPr/>
+          <p:nvPr/>
+        </p:nvSpPr>
+        <p:spPr>
+          <a:xfrm>
+            <a:off x="6446520" y="2212848"/>
+            <a:ext cx="4069080" cy="594360"/>
+          </a:xfrm>
+          <a:prstGeom prst="rect">
+            <a:avLst/>
+          </a:prstGeom>
+          <a:noFill/>
+          <a:ln/>
+        </p:spPr>
+        <p:txBody>
+          <a:bodyPr wrap="square" lIns="0" tIns="0" rIns="0" bIns="0" rtlCol="0" anchor="t"/>
+          <a:lstStyle/>
+          <a:p>
+            <a:pPr rtl="1" algn="r" indent="0" marL="0">
+              <a:buNone/>
+            </a:pPr>
+            <a:r>
+              <a:rPr lang="en-US" sz="1250" dirty="0">
+                <a:solidFill>
+                  <a:srgbClr val="A7ADCE"/>
+                </a:solidFill>
+                <a:latin typeface="Arial" pitchFamily="34" charset="0"/>
+                <a:ea typeface="Arial" pitchFamily="34" charset="-122"/>
+                <a:cs typeface="Arial" pitchFamily="34" charset="-120"/>
+              </a:rPr>
+              <a:t>يبقي النجاح في منطقة النمو (~70–80%).</a:t>
+            </a:r>
+            <a:endParaRPr lang="en-US" sz="1250" dirty="0"/>
+          </a:p>
+        </p:txBody>
+      </p:sp>
+      <p:sp>
+        <p:nvSpPr>
+          <p:cNvPr id="13" name="Shape 11"/>
+          <p:cNvSpPr/>
+          <p:nvPr/>
+        </p:nvSpPr>
+        <p:spPr>
+          <a:xfrm>
+            <a:off x="640080" y="3108960"/>
+            <a:ext cx="5349240" cy="1417320"/>
+          </a:xfrm>
+          <a:prstGeom prst="roundRect">
+            <a:avLst>
+              <a:gd name="adj" fmla="val 7742"/>
+            </a:avLst>
+          </a:prstGeom>
+          <a:solidFill>
+            <a:srgbClr val="1F2748"/>
+          </a:solidFill>
+          <a:ln w="12700">
+            <a:solidFill>
+              <a:srgbClr val="27305A"/>
+            </a:solidFill>
+            <a:prstDash val="solid"/>
+          </a:ln>
+          <a:effectLst>
+            <a:outerShdw sx="100000" sy="100000" kx="0" ky="0" algn="bl" rotWithShape="0" blurRad="101600" dist="38100" dir="5400000">
+              <a:srgbClr val="0A0E20">
+                <a:alpha val="50000"/>
+              </a:srgbClr>
+            </a:outerShdw>
+          </a:effectLst>
+        </p:spPr>
+      </p:sp>
+      <p:sp>
+        <p:nvSpPr>
+          <p:cNvPr id="14" name="Shape 12"/>
+          <p:cNvSpPr/>
+          <p:nvPr/>
+        </p:nvSpPr>
+        <p:spPr>
+          <a:xfrm>
+            <a:off x="5120640" y="3337560"/>
+            <a:ext cx="548640" cy="548640"/>
+          </a:xfrm>
+          <a:prstGeom prst="ellipse">
+            <a:avLst/>
+          </a:prstGeom>
+          <a:solidFill>
+            <a:srgbClr val="27305A"/>
+          </a:solidFill>
+          <a:ln/>
+        </p:spPr>
+      </p:sp>
+      <p:sp>
+        <p:nvSpPr>
+          <p:cNvPr id="15" name="Text 13"/>
+          <p:cNvSpPr/>
+          <p:nvPr/>
+        </p:nvSpPr>
+        <p:spPr>
+          <a:xfrm>
+            <a:off x="5120640" y="3337560"/>
+            <a:ext cx="548640" cy="548640"/>
+          </a:xfrm>
+          <a:prstGeom prst="rect">
+            <a:avLst/>
+          </a:prstGeom>
+          <a:noFill/>
+          <a:ln/>
+        </p:spPr>
+        <p:txBody>
+          <a:bodyPr wrap="square" lIns="0" tIns="0" rIns="0" bIns="0" rtlCol="0" anchor="ctr"/>
+          <a:lstStyle/>
+          <a:p>
+            <a:pPr algn="ctr" indent="0" marL="0">
+              <a:buNone/>
+            </a:pPr>
+            <a:r>
+              <a:rPr lang="en-US" sz="2200" dirty="0">
+                <a:solidFill>
+                  <a:srgbClr val="000000"/>
+                </a:solidFill>
+              </a:rPr>
+              <a:t>💬</a:t>
+            </a:r>
+            <a:endParaRPr lang="en-US" sz="2200" dirty="0"/>
+          </a:p>
+        </p:txBody>
+      </p:sp>
+      <p:sp>
+        <p:nvSpPr>
+          <p:cNvPr id="16" name="Text 14"/>
+          <p:cNvSpPr/>
+          <p:nvPr/>
+        </p:nvSpPr>
+        <p:spPr>
+          <a:xfrm>
+            <a:off x="914400" y="3310128"/>
+            <a:ext cx="4069080" cy="457200"/>
+          </a:xfrm>
+          <a:prstGeom prst="rect">
+            <a:avLst/>
+          </a:prstGeom>
+          <a:noFill/>
+          <a:ln/>
+        </p:spPr>
+        <p:txBody>
+          <a:bodyPr wrap="square" lIns="0" tIns="0" rIns="0" bIns="0" rtlCol="0" anchor="ctr"/>
+          <a:lstStyle/>
+          <a:p>
+            <a:pPr rtl="1" algn="r" indent="0" marL="0">
+              <a:buNone/>
+            </a:pPr>
+            <a:r>
+              <a:rPr lang="en-US" sz="1700" b="1" dirty="0">
+                <a:solidFill>
+                  <a:srgbClr val="EEF1FF"/>
+                </a:solidFill>
+                <a:latin typeface="Arial" pitchFamily="34" charset="0"/>
+                <a:ea typeface="Arial" pitchFamily="34" charset="-122"/>
+                <a:cs typeface="Arial" pitchFamily="34" charset="-120"/>
+              </a:rPr>
+              <a:t>رسالة التشجيع</a:t>
+            </a:r>
+            <a:endParaRPr lang="en-US" sz="1700" dirty="0"/>
+          </a:p>
+        </p:txBody>
+      </p:sp>
+      <p:sp>
+        <p:nvSpPr>
+          <p:cNvPr id="17" name="Text 15"/>
+          <p:cNvSpPr/>
+          <p:nvPr/>
+        </p:nvSpPr>
+        <p:spPr>
+          <a:xfrm>
+            <a:off x="914400" y="3767328"/>
+            <a:ext cx="4069080" cy="594360"/>
+          </a:xfrm>
+          <a:prstGeom prst="rect">
+            <a:avLst/>
+          </a:prstGeom>
+          <a:noFill/>
+          <a:ln/>
+        </p:spPr>
+        <p:txBody>
+          <a:bodyPr wrap="square" lIns="0" tIns="0" rIns="0" bIns="0" rtlCol="0" anchor="t"/>
+          <a:lstStyle/>
+          <a:p>
+            <a:pPr rtl="1" algn="r" indent="0" marL="0">
+              <a:buNone/>
+            </a:pPr>
+            <a:r>
+              <a:rPr lang="en-US" sz="1250" dirty="0">
+                <a:solidFill>
+                  <a:srgbClr val="A7ADCE"/>
+                </a:solidFill>
+                <a:latin typeface="Arial" pitchFamily="34" charset="0"/>
+                <a:ea typeface="Arial" pitchFamily="34" charset="-122"/>
+                <a:cs typeface="Arial" pitchFamily="34" charset="-120"/>
+              </a:rPr>
+              <a:t>داعمة لا موبّخة، حسب السياق.</a:t>
+            </a:r>
+            <a:endParaRPr lang="en-US" sz="1250" dirty="0"/>
+          </a:p>
+        </p:txBody>
+      </p:sp>
+      <p:sp>
+        <p:nvSpPr>
+          <p:cNvPr id="18" name="Shape 16"/>
+          <p:cNvSpPr/>
+          <p:nvPr/>
+        </p:nvSpPr>
+        <p:spPr>
+          <a:xfrm>
+            <a:off x="6172200" y="3108960"/>
+            <a:ext cx="5349240" cy="1417320"/>
+          </a:xfrm>
+          <a:prstGeom prst="roundRect">
+            <a:avLst>
+              <a:gd name="adj" fmla="val 7742"/>
+            </a:avLst>
+          </a:prstGeom>
+          <a:solidFill>
+            <a:srgbClr val="1F2748"/>
+          </a:solidFill>
+          <a:ln w="12700">
+            <a:solidFill>
+              <a:srgbClr val="27305A"/>
+            </a:solidFill>
+            <a:prstDash val="solid"/>
+          </a:ln>
+          <a:effectLst>
+            <a:outerShdw sx="100000" sy="100000" kx="0" ky="0" algn="bl" rotWithShape="0" blurRad="101600" dist="38100" dir="5400000">
+              <a:srgbClr val="0A0E20">
+                <a:alpha val="50000"/>
+              </a:srgbClr>
+            </a:outerShdw>
+          </a:effectLst>
+        </p:spPr>
+      </p:sp>
+      <p:sp>
+        <p:nvSpPr>
           <p:cNvPr id="19" name="Shape 17"/>
           <p:cNvSpPr/>
           <p:nvPr/>
@@ -3437,9 +4884,9 @@
 </p:sld>
 </file>
 
-<file path=ppt/slides/slide12.xml><?xml version="1.0" encoding="utf-8"?>
+<file path=ppt/slides/slide14.xml><?xml version="1.0" encoding="utf-8"?>
 <p:sld xmlns:a="http://schemas.openxmlformats.org/drawingml/2006/main" xmlns:r="http://schemas.openxmlformats.org/officeDocument/2006/relationships" xmlns:p="http://schemas.openxmlformats.org/presentationml/2006/main">
-  <p:cSld name="Slide 12">
+  <p:cSld name="Slide 14">
     <p:bg>
       <p:bgPr>
         <a:solidFill>

</xml_diff>